<commit_message>
Update ai dev gallery slides vslive
</commit_message>
<xml_diff>
--- a/2026/0914_VSLiveSD/AIDevGallery/VSLSD26_ashcraft_ai-dev-gallery.pptx
+++ b/2026/0914_VSLiveSD/AIDevGallery/VSLSD26_ashcraft_ai-dev-gallery.pptx
@@ -821,7 +821,7 @@
           <a:p>
             <a:fld id="{D088F999-7A4E-6B4F-9FED-EF75B73AD044}" type="datetimeFigureOut">
               <a:rPr lang="en-US" smtClean="0"/>
-              <a:t>8/20/2026</a:t>
+              <a:t>9/13/2026</a:t>
             </a:fld>
             <a:endParaRPr lang="en-US"/>
           </a:p>
@@ -989,7 +989,7 @@
           <a:p>
             <a:fld id="{D088F999-7A4E-6B4F-9FED-EF75B73AD044}" type="datetimeFigureOut">
               <a:rPr lang="en-US" smtClean="0"/>
-              <a:t>8/20/2026</a:t>
+              <a:t>9/13/2026</a:t>
             </a:fld>
             <a:endParaRPr lang="en-US"/>
           </a:p>
@@ -1167,7 +1167,7 @@
           <a:p>
             <a:fld id="{D088F999-7A4E-6B4F-9FED-EF75B73AD044}" type="datetimeFigureOut">
               <a:rPr lang="en-US" smtClean="0"/>
-              <a:t>8/20/2026</a:t>
+              <a:t>9/13/2026</a:t>
             </a:fld>
             <a:endParaRPr lang="en-US"/>
           </a:p>
@@ -1336,7 +1336,7 @@
             <a:fld id="{3FE51E94-D08C-431E-88FC-7EB62E529A19}" type="datetimeFigureOut">
               <a:rPr lang="en-US" smtClean="0"/>
               <a:pPr/>
-              <a:t>8/20/2026</a:t>
+              <a:t>9/13/2026</a:t>
             </a:fld>
             <a:endParaRPr lang="en-US"/>
           </a:p>
@@ -1505,7 +1505,7 @@
           <a:p>
             <a:fld id="{D088F999-7A4E-6B4F-9FED-EF75B73AD044}" type="datetimeFigureOut">
               <a:rPr lang="en-US" smtClean="0"/>
-              <a:t>8/20/2026</a:t>
+              <a:t>9/13/2026</a:t>
             </a:fld>
             <a:endParaRPr lang="en-US"/>
           </a:p>
@@ -1750,7 +1750,7 @@
           <a:p>
             <a:fld id="{D088F999-7A4E-6B4F-9FED-EF75B73AD044}" type="datetimeFigureOut">
               <a:rPr lang="en-US" smtClean="0"/>
-              <a:t>8/20/2026</a:t>
+              <a:t>9/13/2026</a:t>
             </a:fld>
             <a:endParaRPr lang="en-US"/>
           </a:p>
@@ -2035,7 +2035,7 @@
           <a:p>
             <a:fld id="{D088F999-7A4E-6B4F-9FED-EF75B73AD044}" type="datetimeFigureOut">
               <a:rPr lang="en-US" smtClean="0"/>
-              <a:t>8/20/2026</a:t>
+              <a:t>9/13/2026</a:t>
             </a:fld>
             <a:endParaRPr lang="en-US"/>
           </a:p>
@@ -2454,7 +2454,7 @@
           <a:p>
             <a:fld id="{D088F999-7A4E-6B4F-9FED-EF75B73AD044}" type="datetimeFigureOut">
               <a:rPr lang="en-US" smtClean="0"/>
-              <a:t>8/20/2026</a:t>
+              <a:t>9/13/2026</a:t>
             </a:fld>
             <a:endParaRPr lang="en-US"/>
           </a:p>
@@ -2571,7 +2571,7 @@
           <a:p>
             <a:fld id="{D088F999-7A4E-6B4F-9FED-EF75B73AD044}" type="datetimeFigureOut">
               <a:rPr lang="en-US" smtClean="0"/>
-              <a:t>8/20/2026</a:t>
+              <a:t>9/13/2026</a:t>
             </a:fld>
             <a:endParaRPr lang="en-US"/>
           </a:p>
@@ -2666,7 +2666,7 @@
           <a:p>
             <a:fld id="{D088F999-7A4E-6B4F-9FED-EF75B73AD044}" type="datetimeFigureOut">
               <a:rPr lang="en-US" smtClean="0"/>
-              <a:t>8/20/2026</a:t>
+              <a:t>9/13/2026</a:t>
             </a:fld>
             <a:endParaRPr lang="en-US"/>
           </a:p>
@@ -2941,7 +2941,7 @@
           <a:p>
             <a:fld id="{D088F999-7A4E-6B4F-9FED-EF75B73AD044}" type="datetimeFigureOut">
               <a:rPr lang="en-US" smtClean="0"/>
-              <a:t>8/20/2026</a:t>
+              <a:t>9/13/2026</a:t>
             </a:fld>
             <a:endParaRPr lang="en-US"/>
           </a:p>
@@ -3193,7 +3193,7 @@
           <a:p>
             <a:fld id="{D088F999-7A4E-6B4F-9FED-EF75B73AD044}" type="datetimeFigureOut">
               <a:rPr lang="en-US" smtClean="0"/>
-              <a:t>8/20/2026</a:t>
+              <a:t>9/13/2026</a:t>
             </a:fld>
             <a:endParaRPr lang="en-US"/>
           </a:p>
@@ -3413,7 +3413,7 @@
           <a:p>
             <a:fld id="{D088F999-7A4E-6B4F-9FED-EF75B73AD044}" type="datetimeFigureOut">
               <a:rPr lang="en-US" smtClean="0"/>
-              <a:t>8/20/2026</a:t>
+              <a:t>9/13/2026</a:t>
             </a:fld>
             <a:endParaRPr lang="en-US"/>
           </a:p>
@@ -3930,7 +3930,7 @@
           <a:p>
             <a:fld id="{D088F999-7A4E-6B4F-9FED-EF75B73AD044}" type="datetimeFigureOut">
               <a:rPr lang="en-US" smtClean="0"/>
-              <a:t>8/20/2026</a:t>
+              <a:t>9/13/2026</a:t>
             </a:fld>
             <a:endParaRPr lang="en-US"/>
           </a:p>
@@ -5755,10 +5755,15 @@
           </p:nvPr>
         </p:nvPicPr>
         <p:blipFill>
-          <a:blip r:embed="rId2"/>
-          <a:stretch>
-            <a:fillRect/>
-          </a:stretch>
+          <a:blip r:embed="rId2" cstate="print">
+            <a:extLst>
+              <a:ext uri="{28A0092B-C50C-407E-A947-70E740481C1C}">
+                <a14:useLocalDpi xmlns:a14="http://schemas.microsoft.com/office/drawing/2010/main" val="0"/>
+              </a:ext>
+            </a:extLst>
+          </a:blip>
+          <a:srcRect/>
+          <a:stretch/>
         </p:blipFill>
         <p:spPr>
           <a:xfrm>

</xml_diff>